<commit_message>
added more to ppt
</commit_message>
<xml_diff>
--- a/predicate_transfer_pruning_presentation.pptx
+++ b/predicate_transfer_pruning_presentation.pptx
@@ -11,8 +11,9 @@
     <p:sldId id="259" r:id="rId5"/>
     <p:sldId id="260" r:id="rId6"/>
     <p:sldId id="261" r:id="rId7"/>
-    <p:sldId id="265" r:id="rId8"/>
-    <p:sldId id="266" r:id="rId9"/>
+    <p:sldId id="267" r:id="rId8"/>
+    <p:sldId id="265" r:id="rId9"/>
+    <p:sldId id="266" r:id="rId10"/>
   </p:sldIdLst>
   <p:sldSz cx="9144000" cy="6858000" type="screen4x3"/>
   <p:notesSz cx="6858000" cy="9144000"/>
@@ -300,7 +301,7 @@
           <a:p>
             <a:fld id="{5BCAD085-E8A6-8845-BD4E-CB4CCA059FC4}" type="datetimeFigureOut">
               <a:rPr lang="en-US" smtClean="0"/>
-              <a:t>11/25/2025</a:t>
+              <a:t>12/8/2025</a:t>
             </a:fld>
             <a:endParaRPr lang="en-US"/>
           </a:p>
@@ -567,7 +568,7 @@
           <a:p>
             <a:fld id="{5BCAD085-E8A6-8845-BD4E-CB4CCA059FC4}" type="datetimeFigureOut">
               <a:rPr lang="en-US" smtClean="0"/>
-              <a:t>11/25/2025</a:t>
+              <a:t>12/8/2025</a:t>
             </a:fld>
             <a:endParaRPr lang="en-US"/>
           </a:p>
@@ -798,7 +799,7 @@
           <a:p>
             <a:fld id="{5BCAD085-E8A6-8845-BD4E-CB4CCA059FC4}" type="datetimeFigureOut">
               <a:rPr lang="en-US" smtClean="0"/>
-              <a:t>11/25/2025</a:t>
+              <a:t>12/8/2025</a:t>
             </a:fld>
             <a:endParaRPr lang="en-US"/>
           </a:p>
@@ -1108,7 +1109,7 @@
           <a:p>
             <a:fld id="{5BCAD085-E8A6-8845-BD4E-CB4CCA059FC4}" type="datetimeFigureOut">
               <a:rPr lang="en-US" smtClean="0"/>
-              <a:t>11/25/2025</a:t>
+              <a:t>12/8/2025</a:t>
             </a:fld>
             <a:endParaRPr lang="en-US"/>
           </a:p>
@@ -1581,7 +1582,7 @@
           <a:p>
             <a:fld id="{5BCAD085-E8A6-8845-BD4E-CB4CCA059FC4}" type="datetimeFigureOut">
               <a:rPr lang="en-US" smtClean="0"/>
-              <a:t>11/25/2025</a:t>
+              <a:t>12/8/2025</a:t>
             </a:fld>
             <a:endParaRPr lang="en-US"/>
           </a:p>
@@ -2128,7 +2129,7 @@
           <a:p>
             <a:fld id="{5BCAD085-E8A6-8845-BD4E-CB4CCA059FC4}" type="datetimeFigureOut">
               <a:rPr lang="en-US" smtClean="0"/>
-              <a:t>11/25/2025</a:t>
+              <a:t>12/8/2025</a:t>
             </a:fld>
             <a:endParaRPr lang="en-US"/>
           </a:p>
@@ -2902,7 +2903,7 @@
           <a:p>
             <a:fld id="{5BCAD085-E8A6-8845-BD4E-CB4CCA059FC4}" type="datetimeFigureOut">
               <a:rPr lang="en-US" smtClean="0"/>
-              <a:t>11/25/2025</a:t>
+              <a:t>12/8/2025</a:t>
             </a:fld>
             <a:endParaRPr lang="en-US"/>
           </a:p>
@@ -3077,7 +3078,7 @@
           <a:p>
             <a:fld id="{5BCAD085-E8A6-8845-BD4E-CB4CCA059FC4}" type="datetimeFigureOut">
               <a:rPr lang="en-US" smtClean="0"/>
-              <a:t>11/25/2025</a:t>
+              <a:t>12/8/2025</a:t>
             </a:fld>
             <a:endParaRPr lang="en-US"/>
           </a:p>
@@ -3300,7 +3301,7 @@
           <a:p>
             <a:fld id="{5BCAD085-E8A6-8845-BD4E-CB4CCA059FC4}" type="datetimeFigureOut">
               <a:rPr lang="en-US" smtClean="0"/>
-              <a:t>11/25/2025</a:t>
+              <a:t>12/8/2025</a:t>
             </a:fld>
             <a:endParaRPr lang="en-US"/>
           </a:p>
@@ -3480,7 +3481,7 @@
           <a:p>
             <a:fld id="{5BCAD085-E8A6-8845-BD4E-CB4CCA059FC4}" type="datetimeFigureOut">
               <a:rPr lang="en-US" smtClean="0"/>
-              <a:t>11/25/2025</a:t>
+              <a:t>12/8/2025</a:t>
             </a:fld>
             <a:endParaRPr lang="en-US"/>
           </a:p>
@@ -3769,7 +3770,7 @@
           <a:p>
             <a:fld id="{5BCAD085-E8A6-8845-BD4E-CB4CCA059FC4}" type="datetimeFigureOut">
               <a:rPr lang="en-US" smtClean="0"/>
-              <a:t>11/25/2025</a:t>
+              <a:t>12/8/2025</a:t>
             </a:fld>
             <a:endParaRPr lang="en-US"/>
           </a:p>
@@ -4011,7 +4012,7 @@
           <a:p>
             <a:fld id="{5BCAD085-E8A6-8845-BD4E-CB4CCA059FC4}" type="datetimeFigureOut">
               <a:rPr lang="en-US" smtClean="0"/>
-              <a:t>11/25/2025</a:t>
+              <a:t>12/8/2025</a:t>
             </a:fld>
             <a:endParaRPr lang="en-US"/>
           </a:p>
@@ -4390,7 +4391,7 @@
           <a:p>
             <a:fld id="{5BCAD085-E8A6-8845-BD4E-CB4CCA059FC4}" type="datetimeFigureOut">
               <a:rPr lang="en-US" smtClean="0"/>
-              <a:t>11/25/2025</a:t>
+              <a:t>12/8/2025</a:t>
             </a:fld>
             <a:endParaRPr lang="en-US"/>
           </a:p>
@@ -4508,7 +4509,7 @@
           <a:p>
             <a:fld id="{5BCAD085-E8A6-8845-BD4E-CB4CCA059FC4}" type="datetimeFigureOut">
               <a:rPr lang="en-US" smtClean="0"/>
-              <a:t>11/25/2025</a:t>
+              <a:t>12/8/2025</a:t>
             </a:fld>
             <a:endParaRPr lang="en-US"/>
           </a:p>
@@ -4603,7 +4604,7 @@
           <a:p>
             <a:fld id="{5BCAD085-E8A6-8845-BD4E-CB4CCA059FC4}" type="datetimeFigureOut">
               <a:rPr lang="en-US" smtClean="0"/>
-              <a:t>11/25/2025</a:t>
+              <a:t>12/8/2025</a:t>
             </a:fld>
             <a:endParaRPr lang="en-US"/>
           </a:p>
@@ -4852,7 +4853,7 @@
           <a:p>
             <a:fld id="{5BCAD085-E8A6-8845-BD4E-CB4CCA059FC4}" type="datetimeFigureOut">
               <a:rPr lang="en-US" smtClean="0"/>
-              <a:t>11/25/2025</a:t>
+              <a:t>12/8/2025</a:t>
             </a:fld>
             <a:endParaRPr lang="en-US"/>
           </a:p>
@@ -5109,7 +5110,7 @@
           <a:p>
             <a:fld id="{5BCAD085-E8A6-8845-BD4E-CB4CCA059FC4}" type="datetimeFigureOut">
               <a:rPr lang="en-US" smtClean="0"/>
-              <a:t>11/25/2025</a:t>
+              <a:t>12/8/2025</a:t>
             </a:fld>
             <a:endParaRPr lang="en-US"/>
           </a:p>
@@ -5352,7 +5353,7 @@
           <a:p>
             <a:fld id="{5BCAD085-E8A6-8845-BD4E-CB4CCA059FC4}" type="datetimeFigureOut">
               <a:rPr lang="en-US" smtClean="0"/>
-              <a:t>11/25/2025</a:t>
+              <a:t>12/8/2025</a:t>
             </a:fld>
             <a:endParaRPr lang="en-US"/>
           </a:p>
@@ -5872,149 +5873,158 @@
           </a:p>
           <a:p>
             <a:pPr>
+              <a:lnSpc>
+                <a:spcPct val="150000"/>
+              </a:lnSpc>
               <a:defRPr sz="1800"/>
             </a:pPr>
             <a:r>
-              <a:rPr dirty="0"/>
+              <a:rPr sz="2400" dirty="0"/>
               <a:t>JOIN </a:t>
             </a:r>
             <a:r>
-              <a:rPr dirty="0" err="1"/>
+              <a:rPr sz="2400" dirty="0" err="1"/>
               <a:t>műveletek</a:t>
             </a:r>
             <a:r>
-              <a:rPr dirty="0"/>
+              <a:rPr sz="2400" dirty="0"/>
               <a:t> </a:t>
             </a:r>
             <a:r>
-              <a:rPr dirty="0" err="1"/>
+              <a:rPr sz="2400" dirty="0" err="1"/>
               <a:t>sok</a:t>
             </a:r>
             <a:r>
-              <a:rPr dirty="0"/>
+              <a:rPr sz="2400" dirty="0"/>
               <a:t> </a:t>
             </a:r>
             <a:r>
-              <a:rPr dirty="0" err="1"/>
+              <a:rPr sz="2400" dirty="0" err="1"/>
               <a:t>felesleges</a:t>
             </a:r>
             <a:r>
-              <a:rPr dirty="0"/>
+              <a:rPr sz="2400" dirty="0"/>
               <a:t> sort </a:t>
             </a:r>
             <a:r>
-              <a:rPr dirty="0" err="1"/>
+              <a:rPr sz="2400" dirty="0" err="1"/>
               <a:t>dolgoznak</a:t>
             </a:r>
             <a:r>
-              <a:rPr dirty="0"/>
+              <a:rPr sz="2400" dirty="0"/>
               <a:t> </a:t>
             </a:r>
             <a:r>
-              <a:rPr dirty="0" err="1"/>
+              <a:rPr sz="2400" dirty="0" err="1"/>
               <a:t>fel</a:t>
             </a:r>
-            <a:endParaRPr dirty="0"/>
+            <a:endParaRPr sz="2400" dirty="0"/>
           </a:p>
           <a:p>
             <a:pPr>
+              <a:lnSpc>
+                <a:spcPct val="150000"/>
+              </a:lnSpc>
               <a:defRPr sz="1800"/>
             </a:pPr>
             <a:r>
-              <a:rPr dirty="0" err="1"/>
+              <a:rPr sz="2400" dirty="0" err="1"/>
               <a:t>Előszűrés</a:t>
             </a:r>
             <a:r>
-              <a:rPr dirty="0"/>
+              <a:rPr sz="2400" dirty="0"/>
               <a:t> </a:t>
             </a:r>
             <a:r>
-              <a:rPr dirty="0" err="1"/>
+              <a:rPr sz="2400" dirty="0" err="1"/>
               <a:t>nélkül</a:t>
             </a:r>
             <a:r>
-              <a:rPr dirty="0"/>
+              <a:rPr sz="2400" dirty="0"/>
               <a:t> a JOIN </a:t>
             </a:r>
             <a:r>
-              <a:rPr dirty="0" err="1"/>
+              <a:rPr sz="2400" dirty="0" err="1"/>
               <a:t>nagyon</a:t>
             </a:r>
             <a:r>
-              <a:rPr dirty="0"/>
+              <a:rPr sz="2400" dirty="0"/>
               <a:t> </a:t>
             </a:r>
             <a:r>
-              <a:rPr dirty="0" err="1"/>
+              <a:rPr sz="2400" dirty="0" err="1"/>
               <a:t>drága</a:t>
             </a:r>
-            <a:endParaRPr dirty="0"/>
+            <a:endParaRPr sz="2400" dirty="0"/>
           </a:p>
           <a:p>
             <a:pPr>
+              <a:lnSpc>
+                <a:spcPct val="150000"/>
+              </a:lnSpc>
               <a:defRPr sz="1800"/>
             </a:pPr>
             <a:r>
-              <a:rPr dirty="0" err="1"/>
+              <a:rPr sz="2400" dirty="0" err="1"/>
               <a:t>Cél</a:t>
             </a:r>
             <a:r>
-              <a:rPr dirty="0"/>
+              <a:rPr sz="2400" dirty="0"/>
               <a:t>: </a:t>
             </a:r>
             <a:r>
-              <a:rPr dirty="0" err="1"/>
+              <a:rPr sz="2400" dirty="0" err="1"/>
               <a:t>minél</a:t>
             </a:r>
             <a:r>
-              <a:rPr dirty="0"/>
+              <a:rPr sz="2400" dirty="0"/>
               <a:t> </a:t>
             </a:r>
             <a:r>
-              <a:rPr dirty="0" err="1"/>
+              <a:rPr sz="2400" dirty="0" err="1"/>
               <a:t>több</a:t>
             </a:r>
             <a:r>
-              <a:rPr dirty="0"/>
+              <a:rPr sz="2400" dirty="0"/>
               <a:t> </a:t>
             </a:r>
             <a:r>
-              <a:rPr dirty="0" err="1"/>
+              <a:rPr sz="2400" dirty="0" err="1"/>
               <a:t>irreleváns</a:t>
             </a:r>
             <a:r>
-              <a:rPr dirty="0"/>
+              <a:rPr sz="2400" dirty="0"/>
               <a:t> </a:t>
             </a:r>
             <a:r>
-              <a:rPr dirty="0" err="1"/>
+              <a:rPr sz="2400" dirty="0" err="1"/>
               <a:t>sor</a:t>
             </a:r>
             <a:r>
-              <a:rPr dirty="0"/>
+              <a:rPr sz="2400" dirty="0"/>
               <a:t> </a:t>
             </a:r>
             <a:r>
-              <a:rPr dirty="0" err="1"/>
+              <a:rPr sz="2400" dirty="0" err="1"/>
               <a:t>eltávolítása</a:t>
             </a:r>
             <a:r>
-              <a:rPr dirty="0"/>
+              <a:rPr sz="2400" dirty="0"/>
               <a:t> </a:t>
             </a:r>
             <a:r>
-              <a:rPr dirty="0" err="1"/>
+              <a:rPr sz="2400" dirty="0" err="1"/>
               <a:t>még</a:t>
             </a:r>
             <a:r>
-              <a:rPr dirty="0"/>
+              <a:rPr sz="2400" dirty="0"/>
               <a:t> JOIN </a:t>
             </a:r>
             <a:r>
-              <a:rPr dirty="0" err="1"/>
+              <a:rPr sz="2400" dirty="0" err="1"/>
               <a:t>előtt</a:t>
             </a:r>
-            <a:endParaRPr dirty="0"/>
+            <a:endParaRPr sz="2400" dirty="0"/>
           </a:p>
         </p:txBody>
       </p:sp>
@@ -6083,164 +6093,176 @@
           </a:p>
           <a:p>
             <a:pPr>
+              <a:lnSpc>
+                <a:spcPct val="150000"/>
+              </a:lnSpc>
               <a:defRPr sz="1800"/>
             </a:pPr>
             <a:r>
-              <a:rPr dirty="0"/>
+              <a:rPr sz="2400" dirty="0"/>
               <a:t>Minden </a:t>
             </a:r>
             <a:r>
-              <a:rPr dirty="0" err="1"/>
+              <a:rPr sz="2400" dirty="0" err="1"/>
               <a:t>tábla</a:t>
             </a:r>
             <a:r>
-              <a:rPr dirty="0"/>
+              <a:rPr sz="2400" dirty="0"/>
               <a:t> Bloom </a:t>
             </a:r>
             <a:r>
-              <a:rPr dirty="0" err="1"/>
+              <a:rPr sz="2400" dirty="0" err="1"/>
               <a:t>filtert</a:t>
             </a:r>
             <a:r>
-              <a:rPr dirty="0"/>
+              <a:rPr sz="2400" dirty="0"/>
               <a:t> </a:t>
             </a:r>
             <a:r>
-              <a:rPr dirty="0" err="1"/>
+              <a:rPr sz="2400" dirty="0" err="1"/>
               <a:t>épít</a:t>
             </a:r>
             <a:r>
-              <a:rPr dirty="0"/>
+              <a:rPr sz="2400" dirty="0"/>
               <a:t> a join </a:t>
             </a:r>
             <a:r>
-              <a:rPr dirty="0" err="1"/>
+              <a:rPr sz="2400" dirty="0" err="1"/>
               <a:t>kulcsaira</a:t>
             </a:r>
-            <a:endParaRPr dirty="0"/>
+            <a:endParaRPr sz="2400" dirty="0"/>
           </a:p>
           <a:p>
             <a:pPr>
+              <a:lnSpc>
+                <a:spcPct val="150000"/>
+              </a:lnSpc>
               <a:defRPr sz="1800"/>
             </a:pPr>
             <a:r>
-              <a:rPr dirty="0"/>
+              <a:rPr sz="2400" dirty="0"/>
               <a:t>A </a:t>
             </a:r>
             <a:r>
-              <a:rPr dirty="0" err="1"/>
+              <a:rPr sz="2400" dirty="0" err="1"/>
               <a:t>filtereket</a:t>
             </a:r>
             <a:r>
-              <a:rPr dirty="0"/>
+              <a:rPr sz="2400" dirty="0"/>
               <a:t> </a:t>
             </a:r>
             <a:r>
-              <a:rPr dirty="0" err="1"/>
+              <a:rPr sz="2400" dirty="0" err="1"/>
               <a:t>átküldik</a:t>
             </a:r>
             <a:r>
-              <a:rPr dirty="0"/>
+              <a:rPr sz="2400" dirty="0"/>
               <a:t> a </a:t>
             </a:r>
             <a:r>
-              <a:rPr dirty="0" err="1"/>
+              <a:rPr sz="2400" dirty="0" err="1"/>
               <a:t>szomszédos</a:t>
             </a:r>
             <a:r>
-              <a:rPr dirty="0"/>
+              <a:rPr sz="2400" dirty="0"/>
               <a:t> </a:t>
             </a:r>
             <a:r>
-              <a:rPr dirty="0" err="1"/>
+              <a:rPr sz="2400" dirty="0" err="1"/>
               <a:t>tábláknak</a:t>
             </a:r>
-            <a:endParaRPr dirty="0"/>
+            <a:endParaRPr sz="2400" dirty="0"/>
           </a:p>
           <a:p>
             <a:pPr>
+              <a:lnSpc>
+                <a:spcPct val="150000"/>
+              </a:lnSpc>
               <a:defRPr sz="1800"/>
             </a:pPr>
             <a:r>
-              <a:rPr dirty="0" err="1"/>
+              <a:rPr sz="2400" dirty="0" err="1"/>
               <a:t>Ahol</a:t>
             </a:r>
             <a:r>
-              <a:rPr dirty="0"/>
+              <a:rPr sz="2400" dirty="0"/>
               <a:t> a </a:t>
             </a:r>
             <a:r>
-              <a:rPr dirty="0" err="1"/>
+              <a:rPr sz="2400" dirty="0" err="1"/>
               <a:t>kulcs</a:t>
             </a:r>
             <a:r>
-              <a:rPr dirty="0"/>
+              <a:rPr sz="2400" dirty="0"/>
               <a:t> </a:t>
             </a:r>
             <a:r>
-              <a:rPr dirty="0" err="1"/>
+              <a:rPr sz="2400" dirty="0" err="1"/>
               <a:t>nem</a:t>
             </a:r>
             <a:r>
-              <a:rPr dirty="0"/>
+              <a:rPr sz="2400" dirty="0"/>
               <a:t> </a:t>
             </a:r>
             <a:r>
-              <a:rPr dirty="0" err="1"/>
+              <a:rPr sz="2400" dirty="0" err="1"/>
               <a:t>lehet</a:t>
             </a:r>
             <a:r>
-              <a:rPr dirty="0"/>
+              <a:rPr sz="2400" dirty="0"/>
               <a:t> </a:t>
             </a:r>
             <a:r>
-              <a:rPr dirty="0" err="1"/>
+              <a:rPr sz="2400" dirty="0" err="1"/>
               <a:t>találat</a:t>
             </a:r>
             <a:r>
-              <a:rPr dirty="0"/>
+              <a:rPr sz="2400" dirty="0"/>
               <a:t> → </a:t>
             </a:r>
             <a:r>
-              <a:rPr dirty="0" err="1"/>
+              <a:rPr sz="2400" dirty="0" err="1"/>
               <a:t>sor</a:t>
             </a:r>
             <a:r>
-              <a:rPr dirty="0"/>
+              <a:rPr sz="2400" dirty="0"/>
               <a:t> </a:t>
             </a:r>
             <a:r>
-              <a:rPr dirty="0" err="1"/>
+              <a:rPr sz="2400" dirty="0" err="1"/>
               <a:t>törölhető</a:t>
             </a:r>
-            <a:endParaRPr dirty="0"/>
+            <a:endParaRPr sz="2400" dirty="0"/>
           </a:p>
           <a:p>
             <a:pPr>
+              <a:lnSpc>
+                <a:spcPct val="150000"/>
+              </a:lnSpc>
               <a:defRPr sz="1800"/>
             </a:pPr>
             <a:r>
-              <a:rPr dirty="0" err="1"/>
+              <a:rPr sz="2400" dirty="0" err="1"/>
               <a:t>Két</a:t>
             </a:r>
             <a:r>
-              <a:rPr dirty="0"/>
+              <a:rPr sz="2400" dirty="0"/>
               <a:t> </a:t>
             </a:r>
             <a:r>
-              <a:rPr dirty="0" err="1"/>
+              <a:rPr sz="2400" dirty="0" err="1"/>
               <a:t>fázis</a:t>
             </a:r>
             <a:r>
-              <a:rPr dirty="0"/>
+              <a:rPr sz="2400" dirty="0"/>
               <a:t>: forward </a:t>
             </a:r>
             <a:r>
-              <a:rPr dirty="0" err="1"/>
+              <a:rPr sz="2400" dirty="0" err="1"/>
               <a:t>és</a:t>
             </a:r>
             <a:r>
-              <a:rPr dirty="0"/>
+              <a:rPr sz="2400" dirty="0"/>
               <a:t> backward pass</a:t>
             </a:r>
           </a:p>
@@ -6304,17 +6326,22 @@
         </p:nvSpPr>
         <p:spPr/>
         <p:txBody>
-          <a:bodyPr/>
+          <a:bodyPr>
+            <a:normAutofit fontScale="92500" lnSpcReduction="10000"/>
+          </a:bodyPr>
           <a:lstStyle/>
           <a:p>
             <a:endParaRPr dirty="0"/>
           </a:p>
           <a:p>
             <a:pPr>
+              <a:lnSpc>
+                <a:spcPct val="150000"/>
+              </a:lnSpc>
               <a:defRPr sz="1800"/>
             </a:pPr>
             <a:r>
-              <a:rPr dirty="0"/>
+              <a:rPr sz="2400" dirty="0"/>
               <a:t>Forward:</a:t>
             </a:r>
           </a:p>
@@ -6337,14 +6364,17 @@
           </a:p>
           <a:p>
             <a:pPr>
+              <a:lnSpc>
+                <a:spcPct val="150000"/>
+              </a:lnSpc>
               <a:defRPr sz="1800"/>
             </a:pPr>
             <a:r>
-              <a:rPr lang="hu-HU" dirty="0" err="1"/>
+              <a:rPr lang="hu-HU" sz="2400" dirty="0" err="1"/>
               <a:t>Backward</a:t>
             </a:r>
             <a:r>
-              <a:rPr lang="hu-HU" dirty="0"/>
+              <a:rPr lang="hu-HU" sz="2400" dirty="0"/>
               <a:t>:</a:t>
             </a:r>
           </a:p>
@@ -6367,17 +6397,20 @@
           </a:p>
           <a:p>
             <a:pPr>
+              <a:lnSpc>
+                <a:spcPct val="160000"/>
+              </a:lnSpc>
               <a:defRPr sz="1800"/>
             </a:pPr>
             <a:r>
-              <a:rPr dirty="0" err="1"/>
+              <a:rPr sz="2400" dirty="0" err="1"/>
               <a:t>Eredmény</a:t>
             </a:r>
             <a:r>
-              <a:rPr dirty="0"/>
+              <a:rPr sz="2400" dirty="0"/>
               <a:t>: </a:t>
             </a:r>
-            <a:endParaRPr lang="hu-HU" dirty="0"/>
+            <a:endParaRPr lang="hu-HU" sz="2400" dirty="0"/>
           </a:p>
           <a:p>
             <a:pPr marL="0" indent="0">
@@ -6480,145 +6513,154 @@
           </a:p>
           <a:p>
             <a:pPr>
+              <a:lnSpc>
+                <a:spcPct val="150000"/>
+              </a:lnSpc>
               <a:defRPr sz="1800"/>
             </a:pPr>
             <a:r>
-              <a:rPr dirty="0"/>
+              <a:rPr sz="2400" dirty="0"/>
               <a:t>Sok predicate transfer </a:t>
             </a:r>
             <a:r>
-              <a:rPr dirty="0" err="1"/>
+              <a:rPr sz="2400" dirty="0" err="1"/>
               <a:t>lépés</a:t>
             </a:r>
             <a:r>
-              <a:rPr dirty="0"/>
+              <a:rPr sz="2400" dirty="0"/>
               <a:t> </a:t>
             </a:r>
             <a:r>
-              <a:rPr dirty="0" err="1"/>
+              <a:rPr sz="2400" dirty="0" err="1"/>
               <a:t>valójában</a:t>
             </a:r>
             <a:r>
-              <a:rPr dirty="0"/>
+              <a:rPr sz="2400" dirty="0"/>
               <a:t> </a:t>
             </a:r>
             <a:r>
-              <a:rPr dirty="0" err="1"/>
+              <a:rPr sz="2400" dirty="0" err="1"/>
               <a:t>semmit</a:t>
             </a:r>
             <a:r>
-              <a:rPr dirty="0"/>
+              <a:rPr sz="2400" dirty="0"/>
               <a:t> </a:t>
             </a:r>
             <a:r>
-              <a:rPr dirty="0" err="1"/>
+              <a:rPr sz="2400" dirty="0" err="1"/>
               <a:t>nem</a:t>
             </a:r>
             <a:r>
-              <a:rPr dirty="0"/>
+              <a:rPr sz="2400" dirty="0"/>
               <a:t> </a:t>
             </a:r>
             <a:r>
-              <a:rPr dirty="0" err="1"/>
+              <a:rPr sz="2400" dirty="0" err="1"/>
               <a:t>szűr</a:t>
             </a:r>
-            <a:endParaRPr dirty="0"/>
+            <a:endParaRPr sz="2400" dirty="0"/>
           </a:p>
           <a:p>
             <a:pPr>
+              <a:lnSpc>
+                <a:spcPct val="150000"/>
+              </a:lnSpc>
               <a:defRPr sz="1800"/>
             </a:pPr>
             <a:r>
-              <a:rPr dirty="0"/>
+              <a:rPr sz="2400" dirty="0"/>
               <a:t>Minden </a:t>
             </a:r>
             <a:r>
-              <a:rPr dirty="0" err="1"/>
+              <a:rPr sz="2400" dirty="0" err="1"/>
               <a:t>fölösleges</a:t>
             </a:r>
             <a:r>
-              <a:rPr dirty="0"/>
+              <a:rPr sz="2400" dirty="0"/>
               <a:t> </a:t>
             </a:r>
             <a:r>
-              <a:rPr dirty="0" err="1"/>
+              <a:rPr sz="2400" dirty="0" err="1"/>
               <a:t>lépés</a:t>
             </a:r>
             <a:r>
-              <a:rPr dirty="0"/>
+              <a:rPr sz="2400" dirty="0"/>
               <a:t> CPU </a:t>
             </a:r>
             <a:r>
-              <a:rPr dirty="0" err="1"/>
+              <a:rPr sz="2400" dirty="0" err="1"/>
               <a:t>és</a:t>
             </a:r>
             <a:r>
-              <a:rPr dirty="0"/>
+              <a:rPr sz="2400" dirty="0"/>
               <a:t> </a:t>
             </a:r>
             <a:r>
-              <a:rPr dirty="0" err="1"/>
+              <a:rPr sz="2400" dirty="0" err="1"/>
               <a:t>hálózati</a:t>
             </a:r>
             <a:r>
-              <a:rPr dirty="0"/>
+              <a:rPr sz="2400" dirty="0"/>
               <a:t> </a:t>
             </a:r>
             <a:r>
-              <a:rPr dirty="0" err="1"/>
+              <a:rPr sz="2400" dirty="0" err="1"/>
               <a:t>költség</a:t>
             </a:r>
-            <a:endParaRPr dirty="0"/>
+            <a:endParaRPr sz="2400" dirty="0"/>
           </a:p>
           <a:p>
             <a:pPr>
+              <a:lnSpc>
+                <a:spcPct val="150000"/>
+              </a:lnSpc>
               <a:defRPr sz="1800"/>
             </a:pPr>
             <a:r>
-              <a:rPr dirty="0" err="1"/>
+              <a:rPr sz="2400" dirty="0" err="1"/>
               <a:t>Cél</a:t>
             </a:r>
             <a:r>
-              <a:rPr dirty="0"/>
+              <a:rPr sz="2400" dirty="0"/>
               <a:t>: </a:t>
             </a:r>
             <a:r>
-              <a:rPr dirty="0" err="1"/>
+              <a:rPr sz="2400" dirty="0" err="1"/>
               <a:t>eldönteni</a:t>
             </a:r>
             <a:r>
-              <a:rPr dirty="0"/>
+              <a:rPr sz="2400" dirty="0"/>
               <a:t>, </a:t>
             </a:r>
             <a:r>
-              <a:rPr dirty="0" err="1"/>
+              <a:rPr sz="2400" dirty="0" err="1"/>
               <a:t>mely</a:t>
             </a:r>
             <a:r>
-              <a:rPr dirty="0"/>
+              <a:rPr sz="2400" dirty="0"/>
               <a:t> </a:t>
             </a:r>
             <a:r>
-              <a:rPr dirty="0" err="1"/>
+              <a:rPr sz="2400" dirty="0" err="1"/>
               <a:t>lépéseket</a:t>
             </a:r>
             <a:r>
-              <a:rPr dirty="0"/>
+              <a:rPr sz="2400" dirty="0"/>
               <a:t> </a:t>
             </a:r>
             <a:r>
-              <a:rPr dirty="0" err="1"/>
+              <a:rPr sz="2400" dirty="0" err="1"/>
               <a:t>érdemes</a:t>
             </a:r>
             <a:r>
-              <a:rPr dirty="0"/>
+              <a:rPr sz="2400" dirty="0"/>
               <a:t> </a:t>
             </a:r>
             <a:r>
-              <a:rPr dirty="0" err="1"/>
+              <a:rPr sz="2400" dirty="0" err="1"/>
               <a:t>megtartani</a:t>
             </a:r>
-            <a:endParaRPr dirty="0"/>
+            <a:endParaRPr sz="2400" dirty="0"/>
           </a:p>
         </p:txBody>
       </p:sp>
@@ -6698,14 +6740,14 @@
               <a:defRPr sz="1800"/>
             </a:pPr>
             <a:r>
-              <a:rPr lang="hu-HU" dirty="0"/>
+              <a:rPr lang="hu-HU" sz="2400" dirty="0"/>
               <a:t>1. </a:t>
             </a:r>
             <a:r>
-              <a:rPr dirty="0"/>
+              <a:rPr sz="2400" dirty="0"/>
               <a:t>Join Key Containment:</a:t>
             </a:r>
-            <a:endParaRPr lang="hu-HU" dirty="0"/>
+            <a:endParaRPr lang="hu-HU" sz="2400" dirty="0"/>
           </a:p>
           <a:p>
             <a:pPr marL="0" indent="0">
@@ -6720,18 +6762,18 @@
               <a:t>	</a:t>
             </a:r>
             <a:r>
-              <a:rPr dirty="0" err="1"/>
+              <a:rPr b="1" dirty="0" err="1"/>
               <a:t>dst.join_keys</a:t>
             </a:r>
             <a:r>
-              <a:rPr dirty="0"/>
+              <a:rPr b="1" dirty="0"/>
               <a:t> ⊆ </a:t>
             </a:r>
             <a:r>
-              <a:rPr dirty="0" err="1"/>
+              <a:rPr b="1" dirty="0" err="1"/>
               <a:t>src.join_keys</a:t>
             </a:r>
-            <a:endParaRPr dirty="0"/>
+            <a:endParaRPr b="1" dirty="0"/>
           </a:p>
           <a:p>
             <a:pPr marL="0" indent="0">
@@ -6742,14 +6784,14 @@
               <a:defRPr sz="1800"/>
             </a:pPr>
             <a:r>
-              <a:rPr lang="hu-HU" dirty="0"/>
+              <a:rPr lang="hu-HU" sz="2400" dirty="0"/>
               <a:t>2. </a:t>
             </a:r>
             <a:r>
-              <a:rPr dirty="0"/>
+              <a:rPr sz="2400" dirty="0"/>
               <a:t>Predicate Containment:</a:t>
             </a:r>
-            <a:endParaRPr lang="hu-HU" dirty="0"/>
+            <a:endParaRPr lang="hu-HU" sz="2400" dirty="0"/>
           </a:p>
           <a:p>
             <a:pPr marL="0" indent="0">
@@ -6764,58 +6806,58 @@
               <a:t>	</a:t>
             </a:r>
             <a:r>
-              <a:rPr dirty="0" err="1"/>
+              <a:rPr b="1" dirty="0" err="1"/>
               <a:t>dst</a:t>
             </a:r>
             <a:r>
-              <a:rPr dirty="0"/>
+              <a:rPr b="1" dirty="0"/>
               <a:t> </a:t>
             </a:r>
             <a:r>
-              <a:rPr dirty="0" err="1"/>
+              <a:rPr b="1" dirty="0" err="1"/>
               <a:t>predikátumai</a:t>
             </a:r>
             <a:r>
-              <a:rPr dirty="0"/>
+              <a:rPr b="1" dirty="0"/>
               <a:t> </a:t>
             </a:r>
             <a:r>
-              <a:rPr dirty="0" err="1"/>
+              <a:rPr b="1" dirty="0" err="1"/>
               <a:t>legalább</a:t>
             </a:r>
             <a:r>
-              <a:rPr dirty="0"/>
+              <a:rPr b="1" dirty="0"/>
               <a:t> </a:t>
             </a:r>
             <a:r>
-              <a:rPr dirty="0" err="1"/>
+              <a:rPr b="1" dirty="0" err="1"/>
               <a:t>olyan</a:t>
             </a:r>
             <a:r>
-              <a:rPr dirty="0"/>
+              <a:rPr b="1" dirty="0"/>
               <a:t> </a:t>
             </a:r>
             <a:r>
-              <a:rPr dirty="0" err="1"/>
+              <a:rPr b="1" dirty="0" err="1"/>
               <a:t>szűkek</a:t>
             </a:r>
             <a:r>
-              <a:rPr dirty="0"/>
+              <a:rPr b="1" dirty="0"/>
               <a:t>, mint a </a:t>
             </a:r>
             <a:r>
-              <a:rPr dirty="0" err="1"/>
+              <a:rPr b="1" dirty="0" err="1"/>
               <a:t>src</a:t>
             </a:r>
             <a:r>
-              <a:rPr dirty="0"/>
+              <a:rPr b="1" dirty="0"/>
               <a:t> </a:t>
             </a:r>
             <a:r>
-              <a:rPr dirty="0" err="1"/>
+              <a:rPr b="1" dirty="0" err="1"/>
               <a:t>predikátumai</a:t>
             </a:r>
-            <a:endParaRPr lang="hu-HU" dirty="0"/>
+            <a:endParaRPr lang="hu-HU" b="1" dirty="0"/>
           </a:p>
           <a:p>
             <a:pPr marL="0" indent="0">
@@ -6826,42 +6868,42 @@
               <a:defRPr sz="1800"/>
             </a:pPr>
             <a:r>
-              <a:rPr lang="hu-HU" dirty="0"/>
+              <a:rPr lang="hu-HU" sz="2400" dirty="0"/>
               <a:t>3. </a:t>
             </a:r>
             <a:r>
-              <a:rPr dirty="0"/>
+              <a:rPr sz="2400" dirty="0"/>
               <a:t>Ha </a:t>
             </a:r>
             <a:r>
-              <a:rPr dirty="0" err="1"/>
+              <a:rPr sz="2400" dirty="0" err="1"/>
               <a:t>mindkettő</a:t>
             </a:r>
             <a:r>
-              <a:rPr dirty="0"/>
+              <a:rPr sz="2400" dirty="0"/>
               <a:t> </a:t>
             </a:r>
             <a:r>
-              <a:rPr dirty="0" err="1"/>
+              <a:rPr sz="2400" dirty="0" err="1"/>
               <a:t>igaz</a:t>
             </a:r>
             <a:r>
-              <a:rPr dirty="0"/>
+              <a:rPr sz="2400" dirty="0"/>
               <a:t> → a </a:t>
             </a:r>
             <a:r>
-              <a:rPr dirty="0" err="1"/>
+              <a:rPr sz="2400" dirty="0" err="1"/>
               <a:t>lépés</a:t>
             </a:r>
             <a:r>
-              <a:rPr dirty="0"/>
+              <a:rPr sz="2400" dirty="0"/>
               <a:t> </a:t>
             </a:r>
             <a:r>
-              <a:rPr dirty="0" err="1"/>
+              <a:rPr sz="2400" dirty="0" err="1"/>
               <a:t>kihagyható</a:t>
             </a:r>
-            <a:endParaRPr dirty="0"/>
+            <a:endParaRPr sz="2400" dirty="0"/>
           </a:p>
         </p:txBody>
       </p:sp>
@@ -6892,6 +6934,175 @@
       </p:grpSpPr>
       <p:sp>
         <p:nvSpPr>
+          <p:cNvPr id="2" name="Cím 1">
+            <a:extLst>
+              <a:ext uri="{FF2B5EF4-FFF2-40B4-BE49-F238E27FC236}">
+                <a16:creationId xmlns:a16="http://schemas.microsoft.com/office/drawing/2014/main" id="{94CF8F9C-89C6-96C3-A701-2E4C89B72CF7}"/>
+              </a:ext>
+            </a:extLst>
+          </p:cNvPr>
+          <p:cNvSpPr>
+            <a:spLocks noGrp="1"/>
+          </p:cNvSpPr>
+          <p:nvPr>
+            <p:ph type="title"/>
+          </p:nvPr>
+        </p:nvSpPr>
+        <p:spPr/>
+        <p:txBody>
+          <a:bodyPr/>
+          <a:lstStyle/>
+          <a:p>
+            <a:r>
+              <a:rPr lang="hu-HU" dirty="0"/>
+              <a:t>Algoritmus</a:t>
+            </a:r>
+          </a:p>
+        </p:txBody>
+      </p:sp>
+      <p:sp>
+        <p:nvSpPr>
+          <p:cNvPr id="3" name="Tartalom helye 2">
+            <a:extLst>
+              <a:ext uri="{FF2B5EF4-FFF2-40B4-BE49-F238E27FC236}">
+                <a16:creationId xmlns:a16="http://schemas.microsoft.com/office/drawing/2014/main" id="{7CA92141-173F-C741-41C8-7B89B65DD6BF}"/>
+              </a:ext>
+            </a:extLst>
+          </p:cNvPr>
+          <p:cNvSpPr>
+            <a:spLocks noGrp="1"/>
+          </p:cNvSpPr>
+          <p:nvPr>
+            <p:ph idx="1"/>
+          </p:nvPr>
+        </p:nvSpPr>
+        <p:spPr>
+          <a:xfrm>
+            <a:off x="594360" y="2682240"/>
+            <a:ext cx="7955280" cy="3581400"/>
+          </a:xfrm>
+        </p:spPr>
+        <p:txBody>
+          <a:bodyPr>
+            <a:normAutofit/>
+          </a:bodyPr>
+          <a:lstStyle/>
+          <a:p>
+            <a:pPr marL="457200" indent="-457200">
+              <a:lnSpc>
+                <a:spcPct val="150000"/>
+              </a:lnSpc>
+              <a:buFont typeface="+mj-lt"/>
+              <a:buAutoNum type="arabicPeriod"/>
+            </a:pPr>
+            <a:r>
+              <a:rPr lang="hu-HU" sz="2400" dirty="0" err="1"/>
+              <a:t>Topológikus</a:t>
+            </a:r>
+            <a:r>
+              <a:rPr lang="hu-HU" sz="2400" dirty="0"/>
+              <a:t> rendezés</a:t>
+            </a:r>
+          </a:p>
+          <a:p>
+            <a:pPr marL="457200" indent="-457200">
+              <a:lnSpc>
+                <a:spcPct val="150000"/>
+              </a:lnSpc>
+              <a:buFont typeface="+mj-lt"/>
+              <a:buAutoNum type="arabicPeriod"/>
+            </a:pPr>
+            <a:r>
+              <a:rPr lang="hu-HU" sz="2400" dirty="0" err="1"/>
+              <a:t>Forward</a:t>
+            </a:r>
+            <a:r>
+              <a:rPr lang="hu-HU" sz="2400" dirty="0"/>
+              <a:t> </a:t>
+            </a:r>
+            <a:r>
+              <a:rPr lang="hu-HU" sz="2400" dirty="0" err="1"/>
+              <a:t>pass</a:t>
+            </a:r>
+            <a:endParaRPr lang="hu-HU" sz="2400" dirty="0"/>
+          </a:p>
+          <a:p>
+            <a:pPr marL="457200" indent="-457200">
+              <a:lnSpc>
+                <a:spcPct val="150000"/>
+              </a:lnSpc>
+              <a:buFont typeface="+mj-lt"/>
+              <a:buAutoNum type="arabicPeriod"/>
+            </a:pPr>
+            <a:r>
+              <a:rPr lang="hu-HU" sz="2400" dirty="0" err="1"/>
+              <a:t>Backward</a:t>
+            </a:r>
+            <a:r>
+              <a:rPr lang="hu-HU" sz="2400" dirty="0"/>
+              <a:t> </a:t>
+            </a:r>
+            <a:r>
+              <a:rPr lang="hu-HU" sz="2400" dirty="0" err="1"/>
+              <a:t>pass</a:t>
+            </a:r>
+            <a:endParaRPr lang="hu-HU" sz="2400" dirty="0"/>
+          </a:p>
+          <a:p>
+            <a:pPr marL="457200" indent="-457200">
+              <a:lnSpc>
+                <a:spcPct val="150000"/>
+              </a:lnSpc>
+              <a:buFont typeface="+mj-lt"/>
+              <a:buAutoNum type="arabicPeriod"/>
+            </a:pPr>
+            <a:r>
+              <a:rPr lang="hu-HU" sz="2400" dirty="0"/>
+              <a:t>(</a:t>
+            </a:r>
+            <a:r>
+              <a:rPr lang="hu-HU" sz="2400" dirty="0" err="1"/>
+              <a:t>Join</a:t>
+            </a:r>
+            <a:r>
+              <a:rPr lang="hu-HU" sz="2400" dirty="0"/>
+              <a:t>)</a:t>
+            </a:r>
+          </a:p>
+        </p:txBody>
+      </p:sp>
+    </p:spTree>
+    <p:extLst>
+      <p:ext uri="{BB962C8B-B14F-4D97-AF65-F5344CB8AC3E}">
+        <p14:creationId xmlns:p14="http://schemas.microsoft.com/office/powerpoint/2010/main" val="138807407"/>
+      </p:ext>
+    </p:extLst>
+  </p:cSld>
+  <p:clrMapOvr>
+    <a:masterClrMapping/>
+  </p:clrMapOvr>
+</p:sld>
+</file>
+
+<file path=ppt/slides/slide8.xml><?xml version="1.0" encoding="utf-8"?>
+<p:sld xmlns:a="http://schemas.openxmlformats.org/drawingml/2006/main" xmlns:r="http://schemas.openxmlformats.org/officeDocument/2006/relationships" xmlns:p="http://schemas.openxmlformats.org/presentationml/2006/main">
+  <p:cSld>
+    <p:spTree>
+      <p:nvGrpSpPr>
+        <p:cNvPr id="1" name=""/>
+        <p:cNvGrpSpPr/>
+        <p:nvPr/>
+      </p:nvGrpSpPr>
+      <p:grpSpPr>
+        <a:xfrm>
+          <a:off x="0" y="0"/>
+          <a:ext cx="0" cy="0"/>
+          <a:chOff x="0" y="0"/>
+          <a:chExt cx="0" cy="0"/>
+        </a:xfrm>
+      </p:grpSpPr>
+      <p:sp>
+        <p:nvSpPr>
           <p:cNvPr id="2" name="Title 1"/>
           <p:cNvSpPr>
             <a:spLocks noGrp="1"/>
@@ -6972,7 +7183,7 @@
 </p:sld>
 </file>
 
-<file path=ppt/slides/slide8.xml><?xml version="1.0" encoding="utf-8"?>
+<file path=ppt/slides/slide9.xml><?xml version="1.0" encoding="utf-8"?>
 <p:sld xmlns:a="http://schemas.openxmlformats.org/drawingml/2006/main" xmlns:r="http://schemas.openxmlformats.org/officeDocument/2006/relationships" xmlns:p="http://schemas.openxmlformats.org/presentationml/2006/main">
   <p:cSld>
     <p:spTree>

</xml_diff>